<commit_message>
Updating exercise to properly use temporary links
</commit_message>
<xml_diff>
--- a/slides/0302-Virtual Screening.pptx
+++ b/slides/0302-Virtual Screening.pptx
@@ -1110,7 +1110,7 @@
           <a:p>
             <a:fld id="{5BCAD085-E8A6-8845-BD4E-CB4CCA059FC4}" type="datetimeFigureOut">
               <a:rPr lang="en-US" smtClean="0"/>
-              <a:t>2/28/26</a:t>
+              <a:t>3/2/26</a:t>
             </a:fld>
             <a:endParaRPr lang="en-US"/>
           </a:p>
@@ -2311,7 +2311,7 @@
           </a:ln>
           <a:extLst>
             <a:ext uri="{C572A759-6A51-4108-AA02-DFA0A04FC94B}">
-              <ma14:wrappingTextBoxFlag xmlns="" xmlns:m="http://schemas.openxmlformats.org/officeDocument/2006/math" xmlns:a14="http://schemas.microsoft.com/office/drawing/2010/main" xmlns:ma14="http://schemas.microsoft.com/office/mac/drawingml/2011/main" val="1"/>
+              <ma14:wrappingTextBoxFlag xmlns:ma14="http://schemas.microsoft.com/office/mac/drawingml/2011/main" xmlns:a14="http://schemas.microsoft.com/office/drawing/2010/main" xmlns:m="http://schemas.openxmlformats.org/officeDocument/2006/math" xmlns="" val="1"/>
             </a:ext>
           </a:extLst>
         </p:spPr>
@@ -2350,7 +2350,7 @@
           </a:ln>
           <a:extLst>
             <a:ext uri="{C572A759-6A51-4108-AA02-DFA0A04FC94B}">
-              <ma14:wrappingTextBoxFlag xmlns="" xmlns:m="http://schemas.openxmlformats.org/officeDocument/2006/math" xmlns:a14="http://schemas.microsoft.com/office/drawing/2010/main" xmlns:ma14="http://schemas.microsoft.com/office/mac/drawingml/2011/main" val="1"/>
+              <ma14:wrappingTextBoxFlag xmlns:ma14="http://schemas.microsoft.com/office/mac/drawingml/2011/main" xmlns:a14="http://schemas.microsoft.com/office/drawing/2010/main" xmlns:m="http://schemas.openxmlformats.org/officeDocument/2006/math" xmlns="" val="1"/>
             </a:ext>
           </a:extLst>
         </p:spPr>
@@ -3246,6 +3246,27 @@
               <a:t> Vina</a:t>
             </a:r>
           </a:p>
+          <a:p>
+            <a:r>
+              <a:rPr lang="en-US" dirty="0"/>
+              <a:t>Structure-Activity </a:t>
+            </a:r>
+            <a:r>
+              <a:rPr lang="en-US"/>
+              <a:t>Relationships by </a:t>
+            </a:r>
+            <a:r>
+              <a:rPr lang="en-US" dirty="0"/>
+              <a:t>catalog, e.g. </a:t>
+            </a:r>
+            <a:r>
+              <a:rPr lang="en-US" dirty="0">
+                <a:hlinkClick r:id="rId2"/>
+              </a:rPr>
+              <a:t>https://cartblanche.docking.org/</a:t>
+            </a:r>
+            <a:endParaRPr lang="en-US" dirty="0"/>
+          </a:p>
         </p:txBody>
       </p:sp>
     </p:spTree>

</xml_diff>